<commit_message>
docs: lesson content updates and 11-exercises audit
- Refresh READMEs across 00k-plan-mode, 02-memory, 03-skills, 05-mcp,
  08-checkpoints with new screenshots and walkthrough images.
- Clean up 04-subagents (remove stale agent example files) and
  08-checkpoints/checkpoint-examples.md.
- Audit 11-exercises index: drop removed modules (01-slash-commands,
  06-hooks, 01-context-engineering), add Spanish translation.
- Fix broken image paths in 02-messy-spreadsheet (lesson-images/).
- 06-evaluate-ai-output: self-contained hook prompt + settings.json
  prereq. 11-connect-systems: explain claude mcp add CLI inline.
- Update web/lib/lessons.ts mapping and screenshot-experiment.

Co-Authored-By: Claude Opus 4.6 (1M context) <noreply@anthropic.com>
</commit_message>
<xml_diff>
--- a/screenshot-experiment/screenshot-vs-text.pptx
+++ b/screenshot-experiment/screenshot-vs-text.pptx
@@ -3084,7 +3084,7 @@
     <p:bg>
       <p:bgPr>
         <a:solidFill>
-          <a:srgbClr val="141418"/>
+          <a:srgbClr val="121216"/>
         </a:solidFill>
         <a:effectLst/>
       </p:bgPr>
@@ -3096,30 +3096,1380 @@
         <p:nvPr/>
       </p:nvGrpSpPr>
       <p:grpSpPr/>
-      <p:pic>
-        <p:nvPicPr>
-          <p:cNvPr id="2" name="Picture 1" descr="linkedin_comparison.png"/>
-          <p:cNvPicPr>
-            <a:picLocks noChangeAspect="1"/>
-          </p:cNvPicPr>
+      <p:sp>
+        <p:nvSpPr>
+          <p:cNvPr id="2" name="TextBox 1"/>
+          <p:cNvSpPr txBox="1"/>
           <p:nvPr/>
-        </p:nvPicPr>
-        <p:blipFill>
-          <a:blip r:embed="rId2"/>
-          <a:stretch>
-            <a:fillRect/>
-          </a:stretch>
-        </p:blipFill>
-        <p:spPr>
-          <a:xfrm>
-            <a:off x="914400" y="548640"/>
-            <a:ext cx="12801600" cy="7132320"/>
+        </p:nvSpPr>
+        <p:spPr>
+          <a:xfrm>
+            <a:off x="914400" y="411480"/>
+            <a:ext cx="12801600" cy="822960"/>
           </a:xfrm>
           <a:prstGeom prst="rect">
             <a:avLst/>
           </a:prstGeom>
-        </p:spPr>
-      </p:pic>
+          <a:noFill/>
+        </p:spPr>
+        <p:txBody>
+          <a:bodyPr wrap="square">
+            <a:spAutoFit/>
+          </a:bodyPr>
+          <a:lstStyle/>
+          <a:p>
+            <a:pPr algn="ctr">
+              <a:defRPr sz="3800" b="1">
+                <a:solidFill>
+                  <a:srgbClr val="FAFAFA"/>
+                </a:solidFill>
+                <a:latin typeface="Outfit"/>
+              </a:defRPr>
+            </a:pPr>
+            <a:r>
+              <a:t>Mismo mensaje. Dos formas de mandárselo a tu AI.</a:t>
+            </a:r>
+          </a:p>
+        </p:txBody>
+      </p:sp>
+      <p:sp>
+        <p:nvSpPr>
+          <p:cNvPr id="3" name="TextBox 2"/>
+          <p:cNvSpPr txBox="1"/>
+          <p:nvPr/>
+        </p:nvSpPr>
+        <p:spPr>
+          <a:xfrm>
+            <a:off x="914400" y="1188720"/>
+            <a:ext cx="12801600" cy="457200"/>
+          </a:xfrm>
+          <a:prstGeom prst="rect">
+            <a:avLst/>
+          </a:prstGeom>
+          <a:noFill/>
+        </p:spPr>
+        <p:txBody>
+          <a:bodyPr wrap="square">
+            <a:spAutoFit/>
+          </a:bodyPr>
+          <a:lstStyle/>
+          <a:p>
+            <a:pPr algn="ctr">
+              <a:defRPr sz="2000" b="0">
+                <a:solidFill>
+                  <a:srgbClr val="A0A0A5"/>
+                </a:solidFill>
+                <a:latin typeface="Plus Jakarta Sans"/>
+              </a:defRPr>
+            </a:pPr>
+            <a:r>
+              <a:t>¿Cuál usas tú?</a:t>
+            </a:r>
+          </a:p>
+        </p:txBody>
+      </p:sp>
+      <p:sp>
+        <p:nvSpPr>
+          <p:cNvPr id="4" name="Rounded Rectangle 3"/>
+          <p:cNvSpPr/>
+          <p:nvPr/>
+        </p:nvSpPr>
+        <p:spPr>
+          <a:xfrm>
+            <a:off x="960120" y="2011680"/>
+            <a:ext cx="6217920" cy="5303520"/>
+          </a:xfrm>
+          <a:prstGeom prst="roundRect">
+            <a:avLst/>
+          </a:prstGeom>
+          <a:solidFill>
+            <a:srgbClr val="121216"/>
+          </a:solidFill>
+          <a:ln>
+            <a:noFill/>
+          </a:ln>
+          <a:effectLst>
+            <a:outerShdw blurRad="600000" dist="0" dir="0">
+              <a:srgbClr val="EF4444">
+                <a:alpha val="25000"/>
+              </a:srgbClr>
+            </a:outerShdw>
+          </a:effectLst>
+        </p:spPr>
+        <p:style>
+          <a:lnRef idx="1">
+            <a:schemeClr val="accent1"/>
+          </a:lnRef>
+          <a:fillRef idx="3">
+            <a:schemeClr val="accent1"/>
+          </a:fillRef>
+          <a:effectRef idx="2">
+            <a:schemeClr val="accent1"/>
+          </a:effectRef>
+          <a:fontRef idx="minor">
+            <a:schemeClr val="lt1"/>
+          </a:fontRef>
+        </p:style>
+        <p:txBody>
+          <a:bodyPr rtlCol="0" anchor="ctr"/>
+          <a:lstStyle/>
+          <a:p>
+            <a:pPr algn="ctr"/>
+          </a:p>
+        </p:txBody>
+      </p:sp>
+      <p:sp>
+        <p:nvSpPr>
+          <p:cNvPr id="5" name="Rounded Rectangle 4"/>
+          <p:cNvSpPr/>
+          <p:nvPr/>
+        </p:nvSpPr>
+        <p:spPr>
+          <a:xfrm>
+            <a:off x="1143000" y="2194560"/>
+            <a:ext cx="5852160" cy="4937760"/>
+          </a:xfrm>
+          <a:prstGeom prst="roundRect">
+            <a:avLst>
+              <a:gd name="adj" fmla="val 6000"/>
+            </a:avLst>
+          </a:prstGeom>
+          <a:solidFill>
+            <a:srgbClr val="26262C"/>
+          </a:solidFill>
+          <a:ln w="19050">
+            <a:solidFill>
+              <a:srgbClr val="EF4444"/>
+            </a:solidFill>
+          </a:ln>
+        </p:spPr>
+        <p:style>
+          <a:lnRef idx="1">
+            <a:schemeClr val="accent1"/>
+          </a:lnRef>
+          <a:fillRef idx="3">
+            <a:schemeClr val="accent1"/>
+          </a:fillRef>
+          <a:effectRef idx="2">
+            <a:schemeClr val="accent1"/>
+          </a:effectRef>
+          <a:fontRef idx="minor">
+            <a:schemeClr val="lt1"/>
+          </a:fontRef>
+        </p:style>
+        <p:txBody>
+          <a:bodyPr rtlCol="0" anchor="ctr"/>
+          <a:lstStyle/>
+          <a:p>
+            <a:pPr algn="ctr"/>
+          </a:p>
+        </p:txBody>
+      </p:sp>
+      <p:sp>
+        <p:nvSpPr>
+          <p:cNvPr id="6" name="Oval 5"/>
+          <p:cNvSpPr/>
+          <p:nvPr/>
+        </p:nvSpPr>
+        <p:spPr>
+          <a:xfrm>
+            <a:off x="3794760" y="2468880"/>
+            <a:ext cx="548640" cy="548640"/>
+          </a:xfrm>
+          <a:prstGeom prst="ellipse">
+            <a:avLst/>
+          </a:prstGeom>
+          <a:noFill/>
+          <a:ln w="31750">
+            <a:solidFill>
+              <a:srgbClr val="EF4444"/>
+            </a:solidFill>
+          </a:ln>
+        </p:spPr>
+        <p:style>
+          <a:lnRef idx="1">
+            <a:schemeClr val="accent1"/>
+          </a:lnRef>
+          <a:fillRef idx="3">
+            <a:schemeClr val="accent1"/>
+          </a:fillRef>
+          <a:effectRef idx="2">
+            <a:schemeClr val="accent1"/>
+          </a:effectRef>
+          <a:fontRef idx="minor">
+            <a:schemeClr val="lt1"/>
+          </a:fontRef>
+        </p:style>
+        <p:txBody>
+          <a:bodyPr rtlCol="0" anchor="ctr"/>
+          <a:lstStyle/>
+          <a:p>
+            <a:pPr algn="ctr"/>
+          </a:p>
+        </p:txBody>
+      </p:sp>
+      <p:sp>
+        <p:nvSpPr>
+          <p:cNvPr id="7" name="Oval 6"/>
+          <p:cNvSpPr/>
+          <p:nvPr/>
+        </p:nvSpPr>
+        <p:spPr>
+          <a:xfrm>
+            <a:off x="3977640" y="2651760"/>
+            <a:ext cx="182880" cy="182880"/>
+          </a:xfrm>
+          <a:prstGeom prst="ellipse">
+            <a:avLst/>
+          </a:prstGeom>
+          <a:solidFill>
+            <a:srgbClr val="EF4444"/>
+          </a:solidFill>
+          <a:ln>
+            <a:noFill/>
+          </a:ln>
+        </p:spPr>
+        <p:style>
+          <a:lnRef idx="1">
+            <a:schemeClr val="accent1"/>
+          </a:lnRef>
+          <a:fillRef idx="3">
+            <a:schemeClr val="accent1"/>
+          </a:fillRef>
+          <a:effectRef idx="2">
+            <a:schemeClr val="accent1"/>
+          </a:effectRef>
+          <a:fontRef idx="minor">
+            <a:schemeClr val="lt1"/>
+          </a:fontRef>
+        </p:style>
+        <p:txBody>
+          <a:bodyPr rtlCol="0" anchor="ctr"/>
+          <a:lstStyle/>
+          <a:p>
+            <a:pPr algn="ctr"/>
+          </a:p>
+        </p:txBody>
+      </p:sp>
+      <p:sp>
+        <p:nvSpPr>
+          <p:cNvPr id="8" name="TextBox 7"/>
+          <p:cNvSpPr txBox="1"/>
+          <p:nvPr/>
+        </p:nvSpPr>
+        <p:spPr>
+          <a:xfrm>
+            <a:off x="1143000" y="3200400"/>
+            <a:ext cx="5852160" cy="457200"/>
+          </a:xfrm>
+          <a:prstGeom prst="rect">
+            <a:avLst/>
+          </a:prstGeom>
+          <a:noFill/>
+        </p:spPr>
+        <p:txBody>
+          <a:bodyPr wrap="square">
+            <a:spAutoFit/>
+          </a:bodyPr>
+          <a:lstStyle/>
+          <a:p>
+            <a:pPr algn="ctr">
+              <a:defRPr sz="2200" b="1">
+                <a:solidFill>
+                  <a:srgbClr val="FAFAFA"/>
+                </a:solidFill>
+                <a:latin typeface="Outfit"/>
+              </a:defRPr>
+            </a:pPr>
+            <a:r>
+              <a:t>Mandar un screenshot</a:t>
+            </a:r>
+          </a:p>
+        </p:txBody>
+      </p:sp>
+      <p:sp>
+        <p:nvSpPr>
+          <p:cNvPr id="9" name="TextBox 8"/>
+          <p:cNvSpPr txBox="1"/>
+          <p:nvPr/>
+        </p:nvSpPr>
+        <p:spPr>
+          <a:xfrm>
+            <a:off x="1143000" y="3749040"/>
+            <a:ext cx="5852160" cy="914400"/>
+          </a:xfrm>
+          <a:prstGeom prst="rect">
+            <a:avLst/>
+          </a:prstGeom>
+          <a:noFill/>
+        </p:spPr>
+        <p:txBody>
+          <a:bodyPr wrap="square">
+            <a:spAutoFit/>
+          </a:bodyPr>
+          <a:lstStyle/>
+          <a:p>
+            <a:pPr algn="ctr">
+              <a:defRPr sz="7200" b="1">
+                <a:solidFill>
+                  <a:srgbClr val="EF4444"/>
+                </a:solidFill>
+                <a:latin typeface="Outfit"/>
+              </a:defRPr>
+            </a:pPr>
+            <a:r>
+              <a:t>1,585</a:t>
+            </a:r>
+          </a:p>
+        </p:txBody>
+      </p:sp>
+      <p:sp>
+        <p:nvSpPr>
+          <p:cNvPr id="10" name="TextBox 9"/>
+          <p:cNvSpPr txBox="1"/>
+          <p:nvPr/>
+        </p:nvSpPr>
+        <p:spPr>
+          <a:xfrm>
+            <a:off x="1143000" y="4617720"/>
+            <a:ext cx="5852160" cy="365760"/>
+          </a:xfrm>
+          <a:prstGeom prst="rect">
+            <a:avLst/>
+          </a:prstGeom>
+          <a:noFill/>
+        </p:spPr>
+        <p:txBody>
+          <a:bodyPr wrap="square">
+            <a:spAutoFit/>
+          </a:bodyPr>
+          <a:lstStyle/>
+          <a:p>
+            <a:pPr algn="ctr">
+              <a:defRPr sz="1800" b="0">
+                <a:solidFill>
+                  <a:srgbClr val="EF4444"/>
+                </a:solidFill>
+                <a:latin typeface="Plus Jakarta Sans"/>
+              </a:defRPr>
+            </a:pPr>
+            <a:r>
+              <a:t>tokens</a:t>
+            </a:r>
+          </a:p>
+        </p:txBody>
+      </p:sp>
+      <p:sp>
+        <p:nvSpPr>
+          <p:cNvPr id="11" name="Rectangle 10"/>
+          <p:cNvSpPr/>
+          <p:nvPr/>
+        </p:nvSpPr>
+        <p:spPr>
+          <a:xfrm>
+            <a:off x="2240280" y="5120640"/>
+            <a:ext cx="3657600" cy="13716"/>
+          </a:xfrm>
+          <a:prstGeom prst="rect">
+            <a:avLst/>
+          </a:prstGeom>
+          <a:solidFill>
+            <a:srgbClr val="46464B"/>
+          </a:solidFill>
+          <a:ln>
+            <a:noFill/>
+          </a:ln>
+        </p:spPr>
+        <p:style>
+          <a:lnRef idx="1">
+            <a:schemeClr val="accent1"/>
+          </a:lnRef>
+          <a:fillRef idx="3">
+            <a:schemeClr val="accent1"/>
+          </a:fillRef>
+          <a:effectRef idx="2">
+            <a:schemeClr val="accent1"/>
+          </a:effectRef>
+          <a:fontRef idx="minor">
+            <a:schemeClr val="lt1"/>
+          </a:fontRef>
+        </p:style>
+        <p:txBody>
+          <a:bodyPr rtlCol="0" anchor="ctr"/>
+          <a:lstStyle/>
+          <a:p>
+            <a:pPr algn="ctr"/>
+          </a:p>
+        </p:txBody>
+      </p:sp>
+      <p:sp>
+        <p:nvSpPr>
+          <p:cNvPr id="12" name="Oval 11"/>
+          <p:cNvSpPr/>
+          <p:nvPr/>
+        </p:nvSpPr>
+        <p:spPr>
+          <a:xfrm>
+            <a:off x="1783080" y="5486400"/>
+            <a:ext cx="91440" cy="91440"/>
+          </a:xfrm>
+          <a:prstGeom prst="ellipse">
+            <a:avLst/>
+          </a:prstGeom>
+          <a:solidFill>
+            <a:srgbClr val="EF4444"/>
+          </a:solidFill>
+          <a:ln>
+            <a:noFill/>
+          </a:ln>
+        </p:spPr>
+        <p:style>
+          <a:lnRef idx="1">
+            <a:schemeClr val="accent1"/>
+          </a:lnRef>
+          <a:fillRef idx="3">
+            <a:schemeClr val="accent1"/>
+          </a:fillRef>
+          <a:effectRef idx="2">
+            <a:schemeClr val="accent1"/>
+          </a:effectRef>
+          <a:fontRef idx="minor">
+            <a:schemeClr val="lt1"/>
+          </a:fontRef>
+        </p:style>
+        <p:txBody>
+          <a:bodyPr rtlCol="0" anchor="ctr"/>
+          <a:lstStyle/>
+          <a:p>
+            <a:pPr algn="ctr"/>
+          </a:p>
+        </p:txBody>
+      </p:sp>
+      <p:sp>
+        <p:nvSpPr>
+          <p:cNvPr id="13" name="TextBox 12"/>
+          <p:cNvSpPr txBox="1"/>
+          <p:nvPr/>
+        </p:nvSpPr>
+        <p:spPr>
+          <a:xfrm>
+            <a:off x="2057400" y="5394960"/>
+            <a:ext cx="4389120" cy="320040"/>
+          </a:xfrm>
+          <a:prstGeom prst="rect">
+            <a:avLst/>
+          </a:prstGeom>
+          <a:noFill/>
+        </p:spPr>
+        <p:txBody>
+          <a:bodyPr wrap="square">
+            <a:spAutoFit/>
+          </a:bodyPr>
+          <a:lstStyle/>
+          <a:p>
+            <a:pPr algn="l">
+              <a:defRPr sz="1400" b="0">
+                <a:solidFill>
+                  <a:srgbClr val="A0A0A5"/>
+                </a:solidFill>
+                <a:latin typeface="Plus Jakarta Sans"/>
+              </a:defRPr>
+            </a:pPr>
+            <a:r>
+              <a:t>La AI tiene que 'leer' la imagen</a:t>
+            </a:r>
+          </a:p>
+        </p:txBody>
+      </p:sp>
+      <p:sp>
+        <p:nvSpPr>
+          <p:cNvPr id="14" name="Oval 13"/>
+          <p:cNvSpPr/>
+          <p:nvPr/>
+        </p:nvSpPr>
+        <p:spPr>
+          <a:xfrm>
+            <a:off x="1783080" y="5897880"/>
+            <a:ext cx="91440" cy="91440"/>
+          </a:xfrm>
+          <a:prstGeom prst="ellipse">
+            <a:avLst/>
+          </a:prstGeom>
+          <a:solidFill>
+            <a:srgbClr val="EF4444"/>
+          </a:solidFill>
+          <a:ln>
+            <a:noFill/>
+          </a:ln>
+        </p:spPr>
+        <p:style>
+          <a:lnRef idx="1">
+            <a:schemeClr val="accent1"/>
+          </a:lnRef>
+          <a:fillRef idx="3">
+            <a:schemeClr val="accent1"/>
+          </a:fillRef>
+          <a:effectRef idx="2">
+            <a:schemeClr val="accent1"/>
+          </a:effectRef>
+          <a:fontRef idx="minor">
+            <a:schemeClr val="lt1"/>
+          </a:fontRef>
+        </p:style>
+        <p:txBody>
+          <a:bodyPr rtlCol="0" anchor="ctr"/>
+          <a:lstStyle/>
+          <a:p>
+            <a:pPr algn="ctr"/>
+          </a:p>
+        </p:txBody>
+      </p:sp>
+      <p:sp>
+        <p:nvSpPr>
+          <p:cNvPr id="15" name="TextBox 14"/>
+          <p:cNvSpPr txBox="1"/>
+          <p:nvPr/>
+        </p:nvSpPr>
+        <p:spPr>
+          <a:xfrm>
+            <a:off x="2057400" y="5806440"/>
+            <a:ext cx="4389120" cy="320040"/>
+          </a:xfrm>
+          <a:prstGeom prst="rect">
+            <a:avLst/>
+          </a:prstGeom>
+          <a:noFill/>
+        </p:spPr>
+        <p:txBody>
+          <a:bodyPr wrap="square">
+            <a:spAutoFit/>
+          </a:bodyPr>
+          <a:lstStyle/>
+          <a:p>
+            <a:pPr algn="l">
+              <a:defRPr sz="1400" b="0">
+                <a:solidFill>
+                  <a:srgbClr val="A0A0A5"/>
+                </a:solidFill>
+                <a:latin typeface="Plus Jakarta Sans"/>
+              </a:defRPr>
+            </a:pPr>
+            <a:r>
+              <a:t>Puede confundir caracteres</a:t>
+            </a:r>
+          </a:p>
+        </p:txBody>
+      </p:sp>
+      <p:sp>
+        <p:nvSpPr>
+          <p:cNvPr id="16" name="Oval 15"/>
+          <p:cNvSpPr/>
+          <p:nvPr/>
+        </p:nvSpPr>
+        <p:spPr>
+          <a:xfrm>
+            <a:off x="1783080" y="6309360"/>
+            <a:ext cx="91440" cy="91440"/>
+          </a:xfrm>
+          <a:prstGeom prst="ellipse">
+            <a:avLst/>
+          </a:prstGeom>
+          <a:solidFill>
+            <a:srgbClr val="EF4444"/>
+          </a:solidFill>
+          <a:ln>
+            <a:noFill/>
+          </a:ln>
+        </p:spPr>
+        <p:style>
+          <a:lnRef idx="1">
+            <a:schemeClr val="accent1"/>
+          </a:lnRef>
+          <a:fillRef idx="3">
+            <a:schemeClr val="accent1"/>
+          </a:fillRef>
+          <a:effectRef idx="2">
+            <a:schemeClr val="accent1"/>
+          </a:effectRef>
+          <a:fontRef idx="minor">
+            <a:schemeClr val="lt1"/>
+          </a:fontRef>
+        </p:style>
+        <p:txBody>
+          <a:bodyPr rtlCol="0" anchor="ctr"/>
+          <a:lstStyle/>
+          <a:p>
+            <a:pPr algn="ctr"/>
+          </a:p>
+        </p:txBody>
+      </p:sp>
+      <p:sp>
+        <p:nvSpPr>
+          <p:cNvPr id="17" name="TextBox 16"/>
+          <p:cNvSpPr txBox="1"/>
+          <p:nvPr/>
+        </p:nvSpPr>
+        <p:spPr>
+          <a:xfrm>
+            <a:off x="2057400" y="6217920"/>
+            <a:ext cx="4389120" cy="320040"/>
+          </a:xfrm>
+          <a:prstGeom prst="rect">
+            <a:avLst/>
+          </a:prstGeom>
+          <a:noFill/>
+        </p:spPr>
+        <p:txBody>
+          <a:bodyPr wrap="square">
+            <a:spAutoFit/>
+          </a:bodyPr>
+          <a:lstStyle/>
+          <a:p>
+            <a:pPr algn="l">
+              <a:defRPr sz="1400" b="0">
+                <a:solidFill>
+                  <a:srgbClr val="A0A0A5"/>
+                </a:solidFill>
+                <a:latin typeface="Plus Jakarta Sans"/>
+              </a:defRPr>
+            </a:pPr>
+            <a:r>
+              <a:t>No puede buscar en tus documentos</a:t>
+            </a:r>
+          </a:p>
+        </p:txBody>
+      </p:sp>
+      <p:sp>
+        <p:nvSpPr>
+          <p:cNvPr id="18" name="Rounded Rectangle 17"/>
+          <p:cNvSpPr/>
+          <p:nvPr/>
+        </p:nvSpPr>
+        <p:spPr>
+          <a:xfrm>
+            <a:off x="7452360" y="2011680"/>
+            <a:ext cx="6217920" cy="5303520"/>
+          </a:xfrm>
+          <a:prstGeom prst="roundRect">
+            <a:avLst/>
+          </a:prstGeom>
+          <a:solidFill>
+            <a:srgbClr val="121216"/>
+          </a:solidFill>
+          <a:ln>
+            <a:noFill/>
+          </a:ln>
+          <a:effectLst>
+            <a:outerShdw blurRad="600000" dist="0" dir="0">
+              <a:srgbClr val="22C55E">
+                <a:alpha val="25000"/>
+              </a:srgbClr>
+            </a:outerShdw>
+          </a:effectLst>
+        </p:spPr>
+        <p:style>
+          <a:lnRef idx="1">
+            <a:schemeClr val="accent1"/>
+          </a:lnRef>
+          <a:fillRef idx="3">
+            <a:schemeClr val="accent1"/>
+          </a:fillRef>
+          <a:effectRef idx="2">
+            <a:schemeClr val="accent1"/>
+          </a:effectRef>
+          <a:fontRef idx="minor">
+            <a:schemeClr val="lt1"/>
+          </a:fontRef>
+        </p:style>
+        <p:txBody>
+          <a:bodyPr rtlCol="0" anchor="ctr"/>
+          <a:lstStyle/>
+          <a:p>
+            <a:pPr algn="ctr"/>
+          </a:p>
+        </p:txBody>
+      </p:sp>
+      <p:sp>
+        <p:nvSpPr>
+          <p:cNvPr id="19" name="Rounded Rectangle 18"/>
+          <p:cNvSpPr/>
+          <p:nvPr/>
+        </p:nvSpPr>
+        <p:spPr>
+          <a:xfrm>
+            <a:off x="7635240" y="2194560"/>
+            <a:ext cx="5852160" cy="4937760"/>
+          </a:xfrm>
+          <a:prstGeom prst="roundRect">
+            <a:avLst>
+              <a:gd name="adj" fmla="val 6000"/>
+            </a:avLst>
+          </a:prstGeom>
+          <a:solidFill>
+            <a:srgbClr val="26262C"/>
+          </a:solidFill>
+          <a:ln w="19050">
+            <a:solidFill>
+              <a:srgbClr val="22C55E"/>
+            </a:solidFill>
+          </a:ln>
+        </p:spPr>
+        <p:style>
+          <a:lnRef idx="1">
+            <a:schemeClr val="accent1"/>
+          </a:lnRef>
+          <a:fillRef idx="3">
+            <a:schemeClr val="accent1"/>
+          </a:fillRef>
+          <a:effectRef idx="2">
+            <a:schemeClr val="accent1"/>
+          </a:effectRef>
+          <a:fontRef idx="minor">
+            <a:schemeClr val="lt1"/>
+          </a:fontRef>
+        </p:style>
+        <p:txBody>
+          <a:bodyPr rtlCol="0" anchor="ctr"/>
+          <a:lstStyle/>
+          <a:p>
+            <a:pPr algn="ctr"/>
+          </a:p>
+        </p:txBody>
+      </p:sp>
+      <p:sp>
+        <p:nvSpPr>
+          <p:cNvPr id="20" name="Rounded Rectangle 19"/>
+          <p:cNvSpPr/>
+          <p:nvPr/>
+        </p:nvSpPr>
+        <p:spPr>
+          <a:xfrm>
+            <a:off x="10360152" y="2606040"/>
+            <a:ext cx="411480" cy="54864"/>
+          </a:xfrm>
+          <a:prstGeom prst="roundRect">
+            <a:avLst/>
+          </a:prstGeom>
+          <a:solidFill>
+            <a:srgbClr val="22C55E"/>
+          </a:solidFill>
+          <a:ln>
+            <a:noFill/>
+          </a:ln>
+        </p:spPr>
+        <p:style>
+          <a:lnRef idx="1">
+            <a:schemeClr val="accent1"/>
+          </a:lnRef>
+          <a:fillRef idx="3">
+            <a:schemeClr val="accent1"/>
+          </a:fillRef>
+          <a:effectRef idx="2">
+            <a:schemeClr val="accent1"/>
+          </a:effectRef>
+          <a:fontRef idx="minor">
+            <a:schemeClr val="lt1"/>
+          </a:fontRef>
+        </p:style>
+        <p:txBody>
+          <a:bodyPr rtlCol="0" anchor="ctr"/>
+          <a:lstStyle/>
+          <a:p>
+            <a:pPr algn="ctr"/>
+          </a:p>
+        </p:txBody>
+      </p:sp>
+      <p:sp>
+        <p:nvSpPr>
+          <p:cNvPr id="21" name="Rounded Rectangle 20"/>
+          <p:cNvSpPr/>
+          <p:nvPr/>
+        </p:nvSpPr>
+        <p:spPr>
+          <a:xfrm>
+            <a:off x="10360152" y="2788920"/>
+            <a:ext cx="320040" cy="54864"/>
+          </a:xfrm>
+          <a:prstGeom prst="roundRect">
+            <a:avLst/>
+          </a:prstGeom>
+          <a:solidFill>
+            <a:srgbClr val="22C55E"/>
+          </a:solidFill>
+          <a:ln>
+            <a:noFill/>
+          </a:ln>
+        </p:spPr>
+        <p:style>
+          <a:lnRef idx="1">
+            <a:schemeClr val="accent1"/>
+          </a:lnRef>
+          <a:fillRef idx="3">
+            <a:schemeClr val="accent1"/>
+          </a:fillRef>
+          <a:effectRef idx="2">
+            <a:schemeClr val="accent1"/>
+          </a:effectRef>
+          <a:fontRef idx="minor">
+            <a:schemeClr val="lt1"/>
+          </a:fontRef>
+        </p:style>
+        <p:txBody>
+          <a:bodyPr rtlCol="0" anchor="ctr"/>
+          <a:lstStyle/>
+          <a:p>
+            <a:pPr algn="ctr"/>
+          </a:p>
+        </p:txBody>
+      </p:sp>
+      <p:sp>
+        <p:nvSpPr>
+          <p:cNvPr id="22" name="Rounded Rectangle 21"/>
+          <p:cNvSpPr/>
+          <p:nvPr/>
+        </p:nvSpPr>
+        <p:spPr>
+          <a:xfrm>
+            <a:off x="10360152" y="2971800"/>
+            <a:ext cx="411480" cy="54864"/>
+          </a:xfrm>
+          <a:prstGeom prst="roundRect">
+            <a:avLst/>
+          </a:prstGeom>
+          <a:solidFill>
+            <a:srgbClr val="22C55E"/>
+          </a:solidFill>
+          <a:ln>
+            <a:noFill/>
+          </a:ln>
+        </p:spPr>
+        <p:style>
+          <a:lnRef idx="1">
+            <a:schemeClr val="accent1"/>
+          </a:lnRef>
+          <a:fillRef idx="3">
+            <a:schemeClr val="accent1"/>
+          </a:fillRef>
+          <a:effectRef idx="2">
+            <a:schemeClr val="accent1"/>
+          </a:effectRef>
+          <a:fontRef idx="minor">
+            <a:schemeClr val="lt1"/>
+          </a:fontRef>
+        </p:style>
+        <p:txBody>
+          <a:bodyPr rtlCol="0" anchor="ctr"/>
+          <a:lstStyle/>
+          <a:p>
+            <a:pPr algn="ctr"/>
+          </a:p>
+        </p:txBody>
+      </p:sp>
+      <p:sp>
+        <p:nvSpPr>
+          <p:cNvPr id="23" name="TextBox 22"/>
+          <p:cNvSpPr txBox="1"/>
+          <p:nvPr/>
+        </p:nvSpPr>
+        <p:spPr>
+          <a:xfrm>
+            <a:off x="7635240" y="3200400"/>
+            <a:ext cx="5852160" cy="457200"/>
+          </a:xfrm>
+          <a:prstGeom prst="rect">
+            <a:avLst/>
+          </a:prstGeom>
+          <a:noFill/>
+        </p:spPr>
+        <p:txBody>
+          <a:bodyPr wrap="square">
+            <a:spAutoFit/>
+          </a:bodyPr>
+          <a:lstStyle/>
+          <a:p>
+            <a:pPr algn="ctr">
+              <a:defRPr sz="2200" b="1">
+                <a:solidFill>
+                  <a:srgbClr val="FAFAFA"/>
+                </a:solidFill>
+                <a:latin typeface="Outfit"/>
+              </a:defRPr>
+            </a:pPr>
+            <a:r>
+              <a:t>Copiar y pegar el texto</a:t>
+            </a:r>
+          </a:p>
+        </p:txBody>
+      </p:sp>
+      <p:sp>
+        <p:nvSpPr>
+          <p:cNvPr id="24" name="TextBox 23"/>
+          <p:cNvSpPr txBox="1"/>
+          <p:nvPr/>
+        </p:nvSpPr>
+        <p:spPr>
+          <a:xfrm>
+            <a:off x="7635240" y="3749040"/>
+            <a:ext cx="5852160" cy="914400"/>
+          </a:xfrm>
+          <a:prstGeom prst="rect">
+            <a:avLst/>
+          </a:prstGeom>
+          <a:noFill/>
+        </p:spPr>
+        <p:txBody>
+          <a:bodyPr wrap="square">
+            <a:spAutoFit/>
+          </a:bodyPr>
+          <a:lstStyle/>
+          <a:p>
+            <a:pPr algn="ctr">
+              <a:defRPr sz="7200" b="1">
+                <a:solidFill>
+                  <a:srgbClr val="22C55E"/>
+                </a:solidFill>
+                <a:latin typeface="Outfit"/>
+              </a:defRPr>
+            </a:pPr>
+            <a:r>
+              <a:t>458</a:t>
+            </a:r>
+          </a:p>
+        </p:txBody>
+      </p:sp>
+      <p:sp>
+        <p:nvSpPr>
+          <p:cNvPr id="25" name="TextBox 24"/>
+          <p:cNvSpPr txBox="1"/>
+          <p:nvPr/>
+        </p:nvSpPr>
+        <p:spPr>
+          <a:xfrm>
+            <a:off x="7635240" y="4617720"/>
+            <a:ext cx="5852160" cy="365760"/>
+          </a:xfrm>
+          <a:prstGeom prst="rect">
+            <a:avLst/>
+          </a:prstGeom>
+          <a:noFill/>
+        </p:spPr>
+        <p:txBody>
+          <a:bodyPr wrap="square">
+            <a:spAutoFit/>
+          </a:bodyPr>
+          <a:lstStyle/>
+          <a:p>
+            <a:pPr algn="ctr">
+              <a:defRPr sz="1800" b="0">
+                <a:solidFill>
+                  <a:srgbClr val="22C55E"/>
+                </a:solidFill>
+                <a:latin typeface="Plus Jakarta Sans"/>
+              </a:defRPr>
+            </a:pPr>
+            <a:r>
+              <a:t>tokens</a:t>
+            </a:r>
+          </a:p>
+        </p:txBody>
+      </p:sp>
+      <p:sp>
+        <p:nvSpPr>
+          <p:cNvPr id="26" name="Rectangle 25"/>
+          <p:cNvSpPr/>
+          <p:nvPr/>
+        </p:nvSpPr>
+        <p:spPr>
+          <a:xfrm>
+            <a:off x="8732520" y="5120640"/>
+            <a:ext cx="3657600" cy="13716"/>
+          </a:xfrm>
+          <a:prstGeom prst="rect">
+            <a:avLst/>
+          </a:prstGeom>
+          <a:solidFill>
+            <a:srgbClr val="46464B"/>
+          </a:solidFill>
+          <a:ln>
+            <a:noFill/>
+          </a:ln>
+        </p:spPr>
+        <p:style>
+          <a:lnRef idx="1">
+            <a:schemeClr val="accent1"/>
+          </a:lnRef>
+          <a:fillRef idx="3">
+            <a:schemeClr val="accent1"/>
+          </a:fillRef>
+          <a:effectRef idx="2">
+            <a:schemeClr val="accent1"/>
+          </a:effectRef>
+          <a:fontRef idx="minor">
+            <a:schemeClr val="lt1"/>
+          </a:fontRef>
+        </p:style>
+        <p:txBody>
+          <a:bodyPr rtlCol="0" anchor="ctr"/>
+          <a:lstStyle/>
+          <a:p>
+            <a:pPr algn="ctr"/>
+          </a:p>
+        </p:txBody>
+      </p:sp>
+      <p:sp>
+        <p:nvSpPr>
+          <p:cNvPr id="27" name="Oval 26"/>
+          <p:cNvSpPr/>
+          <p:nvPr/>
+        </p:nvSpPr>
+        <p:spPr>
+          <a:xfrm>
+            <a:off x="8275320" y="5486400"/>
+            <a:ext cx="91440" cy="91440"/>
+          </a:xfrm>
+          <a:prstGeom prst="ellipse">
+            <a:avLst/>
+          </a:prstGeom>
+          <a:solidFill>
+            <a:srgbClr val="22C55E"/>
+          </a:solidFill>
+          <a:ln>
+            <a:noFill/>
+          </a:ln>
+        </p:spPr>
+        <p:style>
+          <a:lnRef idx="1">
+            <a:schemeClr val="accent1"/>
+          </a:lnRef>
+          <a:fillRef idx="3">
+            <a:schemeClr val="accent1"/>
+          </a:fillRef>
+          <a:effectRef idx="2">
+            <a:schemeClr val="accent1"/>
+          </a:effectRef>
+          <a:fontRef idx="minor">
+            <a:schemeClr val="lt1"/>
+          </a:fontRef>
+        </p:style>
+        <p:txBody>
+          <a:bodyPr rtlCol="0" anchor="ctr"/>
+          <a:lstStyle/>
+          <a:p>
+            <a:pPr algn="ctr"/>
+          </a:p>
+        </p:txBody>
+      </p:sp>
+      <p:sp>
+        <p:nvSpPr>
+          <p:cNvPr id="28" name="TextBox 27"/>
+          <p:cNvSpPr txBox="1"/>
+          <p:nvPr/>
+        </p:nvSpPr>
+        <p:spPr>
+          <a:xfrm>
+            <a:off x="8549640" y="5394960"/>
+            <a:ext cx="4389120" cy="320040"/>
+          </a:xfrm>
+          <a:prstGeom prst="rect">
+            <a:avLst/>
+          </a:prstGeom>
+          <a:noFill/>
+        </p:spPr>
+        <p:txBody>
+          <a:bodyPr wrap="square">
+            <a:spAutoFit/>
+          </a:bodyPr>
+          <a:lstStyle/>
+          <a:p>
+            <a:pPr algn="l">
+              <a:defRPr sz="1400" b="0">
+                <a:solidFill>
+                  <a:srgbClr val="A0A0A5"/>
+                </a:solidFill>
+                <a:latin typeface="Plus Jakarta Sans"/>
+              </a:defRPr>
+            </a:pPr>
+            <a:r>
+              <a:t>La AI lee cada carácter perfecto</a:t>
+            </a:r>
+          </a:p>
+        </p:txBody>
+      </p:sp>
+      <p:sp>
+        <p:nvSpPr>
+          <p:cNvPr id="29" name="Oval 28"/>
+          <p:cNvSpPr/>
+          <p:nvPr/>
+        </p:nvSpPr>
+        <p:spPr>
+          <a:xfrm>
+            <a:off x="8275320" y="5897880"/>
+            <a:ext cx="91440" cy="91440"/>
+          </a:xfrm>
+          <a:prstGeom prst="ellipse">
+            <a:avLst/>
+          </a:prstGeom>
+          <a:solidFill>
+            <a:srgbClr val="22C55E"/>
+          </a:solidFill>
+          <a:ln>
+            <a:noFill/>
+          </a:ln>
+        </p:spPr>
+        <p:style>
+          <a:lnRef idx="1">
+            <a:schemeClr val="accent1"/>
+          </a:lnRef>
+          <a:fillRef idx="3">
+            <a:schemeClr val="accent1"/>
+          </a:fillRef>
+          <a:effectRef idx="2">
+            <a:schemeClr val="accent1"/>
+          </a:effectRef>
+          <a:fontRef idx="minor">
+            <a:schemeClr val="lt1"/>
+          </a:fontRef>
+        </p:style>
+        <p:txBody>
+          <a:bodyPr rtlCol="0" anchor="ctr"/>
+          <a:lstStyle/>
+          <a:p>
+            <a:pPr algn="ctr"/>
+          </a:p>
+        </p:txBody>
+      </p:sp>
+      <p:sp>
+        <p:nvSpPr>
+          <p:cNvPr id="30" name="TextBox 29"/>
+          <p:cNvSpPr txBox="1"/>
+          <p:nvPr/>
+        </p:nvSpPr>
+        <p:spPr>
+          <a:xfrm>
+            <a:off x="8549640" y="5806440"/>
+            <a:ext cx="4389120" cy="320040"/>
+          </a:xfrm>
+          <a:prstGeom prst="rect">
+            <a:avLst/>
+          </a:prstGeom>
+          <a:noFill/>
+        </p:spPr>
+        <p:txBody>
+          <a:bodyPr wrap="square">
+            <a:spAutoFit/>
+          </a:bodyPr>
+          <a:lstStyle/>
+          <a:p>
+            <a:pPr algn="l">
+              <a:defRPr sz="1400" b="0">
+                <a:solidFill>
+                  <a:srgbClr val="A0A0A5"/>
+                </a:solidFill>
+                <a:latin typeface="Plus Jakarta Sans"/>
+              </a:defRPr>
+            </a:pPr>
+            <a:r>
+              <a:t>Cero confusiones</a:t>
+            </a:r>
+          </a:p>
+        </p:txBody>
+      </p:sp>
+      <p:sp>
+        <p:nvSpPr>
+          <p:cNvPr id="31" name="Oval 30"/>
+          <p:cNvSpPr/>
+          <p:nvPr/>
+        </p:nvSpPr>
+        <p:spPr>
+          <a:xfrm>
+            <a:off x="8275320" y="6309360"/>
+            <a:ext cx="91440" cy="91440"/>
+          </a:xfrm>
+          <a:prstGeom prst="ellipse">
+            <a:avLst/>
+          </a:prstGeom>
+          <a:solidFill>
+            <a:srgbClr val="22C55E"/>
+          </a:solidFill>
+          <a:ln>
+            <a:noFill/>
+          </a:ln>
+        </p:spPr>
+        <p:style>
+          <a:lnRef idx="1">
+            <a:schemeClr val="accent1"/>
+          </a:lnRef>
+          <a:fillRef idx="3">
+            <a:schemeClr val="accent1"/>
+          </a:fillRef>
+          <a:effectRef idx="2">
+            <a:schemeClr val="accent1"/>
+          </a:effectRef>
+          <a:fontRef idx="minor">
+            <a:schemeClr val="lt1"/>
+          </a:fontRef>
+        </p:style>
+        <p:txBody>
+          <a:bodyPr rtlCol="0" anchor="ctr"/>
+          <a:lstStyle/>
+          <a:p>
+            <a:pPr algn="ctr"/>
+          </a:p>
+        </p:txBody>
+      </p:sp>
+      <p:sp>
+        <p:nvSpPr>
+          <p:cNvPr id="32" name="TextBox 31"/>
+          <p:cNvSpPr txBox="1"/>
+          <p:nvPr/>
+        </p:nvSpPr>
+        <p:spPr>
+          <a:xfrm>
+            <a:off x="8549640" y="6217920"/>
+            <a:ext cx="4389120" cy="320040"/>
+          </a:xfrm>
+          <a:prstGeom prst="rect">
+            <a:avLst/>
+          </a:prstGeom>
+          <a:noFill/>
+        </p:spPr>
+        <p:txBody>
+          <a:bodyPr wrap="square">
+            <a:spAutoFit/>
+          </a:bodyPr>
+          <a:lstStyle/>
+          <a:p>
+            <a:pPr algn="l">
+              <a:defRPr sz="1400" b="0">
+                <a:solidFill>
+                  <a:srgbClr val="A0A0A5"/>
+                </a:solidFill>
+                <a:latin typeface="Plus Jakarta Sans"/>
+              </a:defRPr>
+            </a:pPr>
+            <a:r>
+              <a:t>Puede buscar directamente en tu código</a:t>
+            </a:r>
+          </a:p>
+        </p:txBody>
+      </p:sp>
+      <p:sp>
+        <p:nvSpPr>
+          <p:cNvPr id="33" name="Rounded Rectangle 32"/>
+          <p:cNvSpPr/>
+          <p:nvPr/>
+        </p:nvSpPr>
+        <p:spPr>
+          <a:xfrm>
+            <a:off x="5120640" y="7498080"/>
+            <a:ext cx="4389120" cy="502920"/>
+          </a:xfrm>
+          <a:prstGeom prst="roundRect">
+            <a:avLst>
+              <a:gd name="adj" fmla="val 50000"/>
+            </a:avLst>
+          </a:prstGeom>
+          <a:solidFill>
+            <a:srgbClr val="EF4444"/>
+          </a:solidFill>
+          <a:ln>
+            <a:noFill/>
+          </a:ln>
+        </p:spPr>
+        <p:style>
+          <a:lnRef idx="1">
+            <a:schemeClr val="accent1"/>
+          </a:lnRef>
+          <a:fillRef idx="3">
+            <a:schemeClr val="accent1"/>
+          </a:fillRef>
+          <a:effectRef idx="2">
+            <a:schemeClr val="accent1"/>
+          </a:effectRef>
+          <a:fontRef idx="minor">
+            <a:schemeClr val="lt1"/>
+          </a:fontRef>
+        </p:style>
+        <p:txBody>
+          <a:bodyPr rtlCol="0" anchor="ctr"/>
+          <a:lstStyle/>
+          <a:p>
+            <a:pPr algn="ctr"/>
+          </a:p>
+        </p:txBody>
+      </p:sp>
+      <p:sp>
+        <p:nvSpPr>
+          <p:cNvPr id="34" name="TextBox 33"/>
+          <p:cNvSpPr txBox="1"/>
+          <p:nvPr/>
+        </p:nvSpPr>
+        <p:spPr>
+          <a:xfrm>
+            <a:off x="5120640" y="7543800"/>
+            <a:ext cx="4389120" cy="502920"/>
+          </a:xfrm>
+          <a:prstGeom prst="rect">
+            <a:avLst/>
+          </a:prstGeom>
+          <a:noFill/>
+        </p:spPr>
+        <p:txBody>
+          <a:bodyPr wrap="square">
+            <a:spAutoFit/>
+          </a:bodyPr>
+          <a:lstStyle/>
+          <a:p>
+            <a:pPr algn="ctr">
+              <a:defRPr sz="1900" b="1">
+                <a:solidFill>
+                  <a:srgbClr val="FFFFFF"/>
+                </a:solidFill>
+                <a:latin typeface="Plus Jakarta Sans"/>
+              </a:defRPr>
+            </a:pPr>
+            <a:r>
+              <a:t>El screenshot cuesta 3.5x más</a:t>
+            </a:r>
+          </a:p>
+        </p:txBody>
+      </p:sp>
+      <p:sp>
+        <p:nvSpPr>
+          <p:cNvPr id="35" name="TextBox 34"/>
+          <p:cNvSpPr txBox="1"/>
+          <p:nvPr/>
+        </p:nvSpPr>
+        <p:spPr>
+          <a:xfrm>
+            <a:off x="914400" y="7818120"/>
+            <a:ext cx="12801600" cy="320040"/>
+          </a:xfrm>
+          <a:prstGeom prst="rect">
+            <a:avLst/>
+          </a:prstGeom>
+          <a:noFill/>
+        </p:spPr>
+        <p:txBody>
+          <a:bodyPr wrap="square">
+            <a:spAutoFit/>
+          </a:bodyPr>
+          <a:lstStyle/>
+          <a:p>
+            <a:pPr algn="ctr">
+              <a:defRPr sz="1100" b="0">
+                <a:solidFill>
+                  <a:srgbClr val="646469"/>
+                </a:solidFill>
+                <a:latin typeface="Plus Jakarta Sans"/>
+              </a:defRPr>
+            </a:pPr>
+            <a:r>
+              <a:t>Medido con la API de Claude  ·  Mismo prompt, mismo modelo</a:t>
+            </a:r>
+          </a:p>
+        </p:txBody>
+      </p:sp>
     </p:spTree>
   </p:cSld>
   <p:clrMapOvr>

</xml_diff>